<commit_message>
Align presentation evidence and clarify future usability work
Update presentation to the verified 79 passing tests. Keep independent human usability review as optional future work without claiming reviewer results.

Co-authored-by: Percy Mduduzi Jr Dlamini <224057855@edu.vut.ac.za>
Co-authored-by: Ungakimi Nkambule <akim.nkambule@icloud.com>
Co-authored-by: Wandile Samuel Mazibuko <224067737@edu.vut.ac.za>
Co-authored-by: Mick Ndaj Kongal <224342924@edu.vut.ac.za>
Co-authored-by: Neo Mokoena <240111699@edu.vut.ac.za>
Co-authored-by: Buhle Refiloe Mdluli <refiloemdluli75@gmail.com>
Co-authored-by: Senamile Nhlanhla <senamilenhl@gmail.com>
Co-authored-by: Sibongiseni John Mokobori <sebongisenijohn@gmail.com>
Co-authored-by: Zama Angel Mtetwa <225039907@edu.vut.ac.za>
</commit_message>
<xml_diff>
--- a/docs/StockSense_AI_Presentation_Review.pptx
+++ b/docs/StockSense_AI_Presentation_Review.pptx
@@ -665,7 +665,7 @@
           <a:lstStyle xmlns:a="http://schemas.openxmlformats.org/drawingml/2006/main"/>
           <a:p xmlns:a="http://schemas.openxmlformats.org/drawingml/2006/main">
             <a:r>
-              <a:t>Proposed speakers: Buhle and Wandile. About 90 seconds. Office copy passed 52 tests on 12 October 2026. Earlier personal-PC rehearsal passed 45 tests. Assistant fresh check: 24/25 supported, 8/8 unrelated rejected. Human usability review is pending.</a:t>
+              <a:t>Proposed speakers: Buhle and Wandile. About 90 seconds. Office copy passed all 79 tests on 16 October 2026, with no skips. Earlier personal-PC rehearsal passed 45 tests. Assistant fresh check: 24/25 supported, 8/8 unrelated rejected. Human usability review is pending.</a:t>
             </a:r>
           </a:p>
         </p:txBody>
@@ -5943,7 +5943,7 @@
                 <a:ea typeface="Arial"/>
                 <a:cs typeface="Arial"/>
               </a:rPr>
-              <a:t>52</a:t>
+              <a:t>79</a:t>
             </a:r>
           </a:p>
         </p:txBody>

</xml_diff>